<commit_message>
Match AHP flowchart colors to reference image (light theme)
- White background with blue/teal/navy palette
- Per-step circle styles: outline blue, filled light blue, outline teal, outline navy
- Two-tone timeline line matching original design

Co-authored-by: sazmanfava854-sudo <sazmanfava854-sudo@users.noreply.github.com>
</commit_message>
<xml_diff>
--- a/docs/AHP_Workflow_Flowchart.pptx
+++ b/docs/AHP_Workflow_Flowchart.pptx
@@ -3091,7 +3091,7 @@
     <p:bg>
       <p:bgPr>
         <a:solidFill>
-          <a:srgbClr val="0C0E14"/>
+          <a:srgbClr val="FFFFFF"/>
         </a:solidFill>
         <a:effectLst/>
       </p:bgPr>
@@ -3128,7 +3128,7 @@
             <a:pPr algn="ctr">
               <a:defRPr sz="2400" b="1">
                 <a:solidFill>
-                  <a:srgbClr val="FFFFFF"/>
+                  <a:srgbClr val="1E3A8A"/>
                 </a:solidFill>
               </a:defRPr>
             </a:pPr>
@@ -3213,7 +3213,7 @@
             <a:pPr algn="r">
               <a:defRPr sz="2800" b="1">
                 <a:solidFill>
-                  <a:srgbClr val="143C8C"/>
+                  <a:srgbClr val="1E3A8A"/>
                 </a:solidFill>
               </a:defRPr>
             </a:pPr>
@@ -3251,7 +3251,7 @@
               </a:spcAft>
               <a:defRPr sz="1800">
                 <a:solidFill>
-                  <a:srgbClr val="283246"/>
+                  <a:srgbClr val="1E293B"/>
                 </a:solidFill>
               </a:defRPr>
             </a:pPr>
@@ -3266,7 +3266,7 @@
               </a:spcAft>
               <a:defRPr sz="1800">
                 <a:solidFill>
-                  <a:srgbClr val="283246"/>
+                  <a:srgbClr val="1E293B"/>
                 </a:solidFill>
               </a:defRPr>
             </a:pPr>
@@ -3281,7 +3281,7 @@
               </a:spcAft>
               <a:defRPr sz="1800">
                 <a:solidFill>
-                  <a:srgbClr val="283246"/>
+                  <a:srgbClr val="1E293B"/>
                 </a:solidFill>
               </a:defRPr>
             </a:pPr>
@@ -3311,7 +3311,7 @@
               </a:spcAft>
               <a:defRPr sz="1800">
                 <a:solidFill>
-                  <a:srgbClr val="283246"/>
+                  <a:srgbClr val="1E293B"/>
                 </a:solidFill>
               </a:defRPr>
             </a:pPr>
@@ -3326,7 +3326,7 @@
               </a:spcAft>
               <a:defRPr sz="1800">
                 <a:solidFill>
-                  <a:srgbClr val="283246"/>
+                  <a:srgbClr val="1E293B"/>
                 </a:solidFill>
               </a:defRPr>
             </a:pPr>
@@ -3341,7 +3341,7 @@
               </a:spcAft>
               <a:defRPr sz="1800">
                 <a:solidFill>
-                  <a:srgbClr val="283246"/>
+                  <a:srgbClr val="1E293B"/>
                 </a:solidFill>
               </a:defRPr>
             </a:pPr>
@@ -3402,7 +3402,7 @@
             <a:pPr algn="r">
               <a:defRPr sz="3200" b="1">
                 <a:solidFill>
-                  <a:srgbClr val="143C8C"/>
+                  <a:srgbClr val="1E3A8A"/>
                 </a:solidFill>
               </a:defRPr>
             </a:pPr>
@@ -3417,7 +3417,7 @@
               </a:spcBef>
               <a:defRPr sz="2200">
                 <a:solidFill>
-                  <a:srgbClr val="465064"/>
+                  <a:srgbClr val="64748B"/>
                 </a:solidFill>
               </a:defRPr>
             </a:pPr>
@@ -3478,7 +3478,7 @@
             <a:pPr algn="r">
               <a:defRPr sz="3200" b="1">
                 <a:solidFill>
-                  <a:srgbClr val="143C8C"/>
+                  <a:srgbClr val="1E3A8A"/>
                 </a:solidFill>
               </a:defRPr>
             </a:pPr>
@@ -3493,7 +3493,7 @@
               </a:spcBef>
               <a:defRPr sz="2200">
                 <a:solidFill>
-                  <a:srgbClr val="465064"/>
+                  <a:srgbClr val="64748B"/>
                 </a:solidFill>
               </a:defRPr>
             </a:pPr>
@@ -3554,7 +3554,7 @@
             <a:pPr algn="r">
               <a:defRPr sz="3200" b="1">
                 <a:solidFill>
-                  <a:srgbClr val="143C8C"/>
+                  <a:srgbClr val="1E3A8A"/>
                 </a:solidFill>
               </a:defRPr>
             </a:pPr>
@@ -3569,7 +3569,7 @@
               </a:spcBef>
               <a:defRPr sz="2200">
                 <a:solidFill>
-                  <a:srgbClr val="465064"/>
+                  <a:srgbClr val="64748B"/>
                 </a:solidFill>
               </a:defRPr>
             </a:pPr>
@@ -3630,7 +3630,7 @@
             <a:pPr algn="r">
               <a:defRPr sz="3200" b="1">
                 <a:solidFill>
-                  <a:srgbClr val="143C8C"/>
+                  <a:srgbClr val="1E3A8A"/>
                 </a:solidFill>
               </a:defRPr>
             </a:pPr>
@@ -3645,7 +3645,7 @@
               </a:spcBef>
               <a:defRPr sz="2200">
                 <a:solidFill>
-                  <a:srgbClr val="465064"/>
+                  <a:srgbClr val="64748B"/>
                 </a:solidFill>
               </a:defRPr>
             </a:pPr>
@@ -3706,7 +3706,7 @@
             <a:pPr algn="r">
               <a:defRPr sz="3200" b="1">
                 <a:solidFill>
-                  <a:srgbClr val="143C8C"/>
+                  <a:srgbClr val="1E3A8A"/>
                 </a:solidFill>
               </a:defRPr>
             </a:pPr>
@@ -3721,7 +3721,7 @@
               </a:spcBef>
               <a:defRPr sz="2200">
                 <a:solidFill>
-                  <a:srgbClr val="465064"/>
+                  <a:srgbClr val="64748B"/>
                 </a:solidFill>
               </a:defRPr>
             </a:pPr>
@@ -3782,7 +3782,7 @@
             <a:pPr algn="r">
               <a:defRPr sz="3200" b="1">
                 <a:solidFill>
-                  <a:srgbClr val="143C8C"/>
+                  <a:srgbClr val="1E3A8A"/>
                 </a:solidFill>
               </a:defRPr>
             </a:pPr>
@@ -3797,7 +3797,7 @@
               </a:spcBef>
               <a:defRPr sz="2200">
                 <a:solidFill>
-                  <a:srgbClr val="465064"/>
+                  <a:srgbClr val="64748B"/>
                 </a:solidFill>
               </a:defRPr>
             </a:pPr>

</xml_diff>